<commit_message>
Finalize Asthimitra brand: azure+amber A-Bone logo across apps, deck, index; add logo/favicon assets
Co-Authored-By: Claude Opus 4.8 <noreply@anthropic.com>
</commit_message>
<xml_diff>
--- a/Asthimitra_Overview.pptx
+++ b/Asthimitra_Overview.pptx
@@ -3110,7 +3110,7 @@
             <a:avLst/>
           </a:prstGeom>
           <a:solidFill>
-            <a:srgbClr val="0E5A54"/>
+            <a:srgbClr val="1466C7"/>
           </a:solidFill>
           <a:ln>
             <a:noFill/>
@@ -3154,7 +3154,7 @@
             <a:avLst/>
           </a:prstGeom>
           <a:solidFill>
-            <a:srgbClr val="0B4741"/>
+            <a:srgbClr val="0E4C97"/>
           </a:solidFill>
           <a:ln>
             <a:noFill/>
@@ -3183,22 +3183,130 @@
           </a:p>
         </p:txBody>
       </p:sp>
-      <p:sp>
-        <p:nvSpPr>
-          <p:cNvPr id="4" name="Rounded Rectangle 3"/>
+      <p:cxnSp>
+        <p:nvCxnSpPr>
+          <p:cNvPr id="4" name="Connector 3"/>
+          <p:cNvCxnSpPr/>
+          <p:nvPr/>
+        </p:nvCxnSpPr>
+        <p:spPr>
+          <a:xfrm flipH="1">
+            <a:off x="1053388" y="914400"/>
+            <a:ext cx="181052" cy="510235"/>
+          </a:xfrm>
+          <a:prstGeom prst="line">
+            <a:avLst/>
+          </a:prstGeom>
+          <a:ln w="98755" cap="rnd">
+            <a:solidFill>
+              <a:srgbClr val="FFFFFF"/>
+            </a:solidFill>
+          </a:ln>
+          <a:effectLst/>
+        </p:spPr>
+        <p:style>
+          <a:lnRef idx="2">
+            <a:schemeClr val="accent1"/>
+          </a:lnRef>
+          <a:fillRef idx="0">
+            <a:schemeClr val="accent1"/>
+          </a:fillRef>
+          <a:effectRef idx="1">
+            <a:schemeClr val="accent1"/>
+          </a:effectRef>
+          <a:fontRef idx="minor">
+            <a:schemeClr val="tx1"/>
+          </a:fontRef>
+        </p:style>
+      </p:cxnSp>
+      <p:cxnSp>
+        <p:nvCxnSpPr>
+          <p:cNvPr id="5" name="Connector 4"/>
+          <p:cNvCxnSpPr/>
+          <p:nvPr/>
+        </p:nvCxnSpPr>
+        <p:spPr>
+          <a:xfrm>
+            <a:off x="1234440" y="914400"/>
+            <a:ext cx="181051" cy="510235"/>
+          </a:xfrm>
+          <a:prstGeom prst="line">
+            <a:avLst/>
+          </a:prstGeom>
+          <a:ln w="98755" cap="rnd">
+            <a:solidFill>
+              <a:srgbClr val="FFFFFF"/>
+            </a:solidFill>
+          </a:ln>
+          <a:effectLst/>
+        </p:spPr>
+        <p:style>
+          <a:lnRef idx="2">
+            <a:schemeClr val="accent1"/>
+          </a:lnRef>
+          <a:fillRef idx="0">
+            <a:schemeClr val="accent1"/>
+          </a:fillRef>
+          <a:effectRef idx="1">
+            <a:schemeClr val="accent1"/>
+          </a:effectRef>
+          <a:fontRef idx="minor">
+            <a:schemeClr val="tx1"/>
+          </a:fontRef>
+        </p:style>
+      </p:cxnSp>
+      <p:cxnSp>
+        <p:nvCxnSpPr>
+          <p:cNvPr id="6" name="Connector 5"/>
+          <p:cNvCxnSpPr/>
+          <p:nvPr/>
+        </p:nvCxnSpPr>
+        <p:spPr>
+          <a:xfrm>
+            <a:off x="1086307" y="1218895"/>
+            <a:ext cx="296265" cy="0"/>
+          </a:xfrm>
+          <a:prstGeom prst="line">
+            <a:avLst/>
+          </a:prstGeom>
+          <a:ln w="98755" cap="rnd">
+            <a:solidFill>
+              <a:srgbClr val="F4B23C"/>
+            </a:solidFill>
+          </a:ln>
+          <a:effectLst/>
+        </p:spPr>
+        <p:style>
+          <a:lnRef idx="2">
+            <a:schemeClr val="accent1"/>
+          </a:lnRef>
+          <a:fillRef idx="0">
+            <a:schemeClr val="accent1"/>
+          </a:fillRef>
+          <a:effectRef idx="1">
+            <a:schemeClr val="accent1"/>
+          </a:effectRef>
+          <a:fontRef idx="minor">
+            <a:schemeClr val="tx1"/>
+          </a:fontRef>
+        </p:style>
+      </p:cxnSp>
+      <p:sp>
+        <p:nvSpPr>
+          <p:cNvPr id="7" name="Oval 6"/>
           <p:cNvSpPr/>
           <p:nvPr/>
         </p:nvSpPr>
         <p:spPr>
           <a:xfrm>
-            <a:off x="822960" y="731520"/>
-            <a:ext cx="822960" cy="822960"/>
-          </a:xfrm>
-          <a:prstGeom prst="roundRect">
+            <a:off x="1004011" y="1087222"/>
+            <a:ext cx="148132" cy="148132"/>
+          </a:xfrm>
+          <a:prstGeom prst="ellipse">
             <a:avLst/>
           </a:prstGeom>
           <a:solidFill>
-            <a:srgbClr val="DC6B4F"/>
+            <a:srgbClr val="F4B23C"/>
           </a:solidFill>
           <a:ln>
             <a:noFill/>
@@ -3229,49 +3337,139 @@
       </p:sp>
       <p:sp>
         <p:nvSpPr>
-          <p:cNvPr id="5" name="TextBox 4"/>
-          <p:cNvSpPr txBox="1"/>
-          <p:nvPr/>
-        </p:nvSpPr>
-        <p:spPr>
-          <a:xfrm>
-            <a:off x="822960" y="786384"/>
-            <a:ext cx="822960" cy="731520"/>
-          </a:xfrm>
-          <a:prstGeom prst="rect">
-            <a:avLst/>
-          </a:prstGeom>
-          <a:noFill/>
-        </p:spPr>
-        <p:txBody>
-          <a:bodyPr wrap="square" anchor="ctr" lIns="0" rIns="0" tIns="0" bIns="0">
-            <a:spAutoFit/>
-          </a:bodyPr>
-          <a:lstStyle/>
-          <a:p>
-            <a:pPr algn="ctr">
-              <a:spcBef>
-                <a:spcPts val="0"/>
-              </a:spcBef>
-              <a:spcAft>
-                <a:spcPts val="600"/>
-              </a:spcAft>
-            </a:pPr>
-            <a:r>
-              <a:rPr sz="3400" b="1">
-                <a:solidFill>
-                  <a:srgbClr val="FFFFFF"/>
-                </a:solidFill>
-                <a:latin typeface="Calibri"/>
-              </a:rPr>
-              <a:t>♥</a:t>
-            </a:r>
-          </a:p>
-        </p:txBody>
-      </p:sp>
-      <p:sp>
-        <p:nvSpPr>
-          <p:cNvPr id="6" name="TextBox 5"/>
+          <p:cNvPr id="8" name="Oval 7"/>
+          <p:cNvSpPr/>
+          <p:nvPr/>
+        </p:nvSpPr>
+        <p:spPr>
+          <a:xfrm>
+            <a:off x="1004011" y="1202436"/>
+            <a:ext cx="148132" cy="148132"/>
+          </a:xfrm>
+          <a:prstGeom prst="ellipse">
+            <a:avLst/>
+          </a:prstGeom>
+          <a:solidFill>
+            <a:srgbClr val="F4B23C"/>
+          </a:solidFill>
+          <a:ln>
+            <a:noFill/>
+          </a:ln>
+          <a:effectLst/>
+        </p:spPr>
+        <p:style>
+          <a:lnRef idx="1">
+            <a:schemeClr val="accent1"/>
+          </a:lnRef>
+          <a:fillRef idx="3">
+            <a:schemeClr val="accent1"/>
+          </a:fillRef>
+          <a:effectRef idx="2">
+            <a:schemeClr val="accent1"/>
+          </a:effectRef>
+          <a:fontRef idx="minor">
+            <a:schemeClr val="lt1"/>
+          </a:fontRef>
+        </p:style>
+        <p:txBody>
+          <a:bodyPr rtlCol="0" anchor="ctr"/>
+          <a:lstStyle/>
+          <a:p>
+            <a:pPr algn="ctr"/>
+          </a:p>
+        </p:txBody>
+      </p:sp>
+      <p:sp>
+        <p:nvSpPr>
+          <p:cNvPr id="9" name="Oval 8"/>
+          <p:cNvSpPr/>
+          <p:nvPr/>
+        </p:nvSpPr>
+        <p:spPr>
+          <a:xfrm>
+            <a:off x="1316736" y="1087222"/>
+            <a:ext cx="148132" cy="148132"/>
+          </a:xfrm>
+          <a:prstGeom prst="ellipse">
+            <a:avLst/>
+          </a:prstGeom>
+          <a:solidFill>
+            <a:srgbClr val="F4B23C"/>
+          </a:solidFill>
+          <a:ln>
+            <a:noFill/>
+          </a:ln>
+          <a:effectLst/>
+        </p:spPr>
+        <p:style>
+          <a:lnRef idx="1">
+            <a:schemeClr val="accent1"/>
+          </a:lnRef>
+          <a:fillRef idx="3">
+            <a:schemeClr val="accent1"/>
+          </a:fillRef>
+          <a:effectRef idx="2">
+            <a:schemeClr val="accent1"/>
+          </a:effectRef>
+          <a:fontRef idx="minor">
+            <a:schemeClr val="lt1"/>
+          </a:fontRef>
+        </p:style>
+        <p:txBody>
+          <a:bodyPr rtlCol="0" anchor="ctr"/>
+          <a:lstStyle/>
+          <a:p>
+            <a:pPr algn="ctr"/>
+          </a:p>
+        </p:txBody>
+      </p:sp>
+      <p:sp>
+        <p:nvSpPr>
+          <p:cNvPr id="10" name="Oval 9"/>
+          <p:cNvSpPr/>
+          <p:nvPr/>
+        </p:nvSpPr>
+        <p:spPr>
+          <a:xfrm>
+            <a:off x="1316736" y="1202436"/>
+            <a:ext cx="148132" cy="148132"/>
+          </a:xfrm>
+          <a:prstGeom prst="ellipse">
+            <a:avLst/>
+          </a:prstGeom>
+          <a:solidFill>
+            <a:srgbClr val="F4B23C"/>
+          </a:solidFill>
+          <a:ln>
+            <a:noFill/>
+          </a:ln>
+          <a:effectLst/>
+        </p:spPr>
+        <p:style>
+          <a:lnRef idx="1">
+            <a:schemeClr val="accent1"/>
+          </a:lnRef>
+          <a:fillRef idx="3">
+            <a:schemeClr val="accent1"/>
+          </a:fillRef>
+          <a:effectRef idx="2">
+            <a:schemeClr val="accent1"/>
+          </a:effectRef>
+          <a:fontRef idx="minor">
+            <a:schemeClr val="lt1"/>
+          </a:fontRef>
+        </p:style>
+        <p:txBody>
+          <a:bodyPr rtlCol="0" anchor="ctr"/>
+          <a:lstStyle/>
+          <a:p>
+            <a:pPr algn="ctr"/>
+          </a:p>
+        </p:txBody>
+      </p:sp>
+      <p:sp>
+        <p:nvSpPr>
+          <p:cNvPr id="11" name="TextBox 10"/>
           <p:cNvSpPr txBox="1"/>
           <p:nvPr/>
         </p:nvSpPr>
@@ -3313,7 +3511,7 @@
       </p:sp>
       <p:sp>
         <p:nvSpPr>
-          <p:cNvPr id="7" name="TextBox 6"/>
+          <p:cNvPr id="12" name="TextBox 11"/>
           <p:cNvSpPr txBox="1"/>
           <p:nvPr/>
         </p:nvSpPr>
@@ -3374,7 +3572,7 @@
       </p:sp>
       <p:sp>
         <p:nvSpPr>
-          <p:cNvPr id="8" name="Rectangle 7"/>
+          <p:cNvPr id="13" name="Rectangle 12"/>
           <p:cNvSpPr/>
           <p:nvPr/>
         </p:nvSpPr>
@@ -3387,7 +3585,7 @@
             <a:avLst/>
           </a:prstGeom>
           <a:solidFill>
-            <a:srgbClr val="DC6B4F"/>
+            <a:srgbClr val="E0930F"/>
           </a:solidFill>
           <a:ln>
             <a:noFill/>
@@ -3418,7 +3616,7 @@
       </p:sp>
       <p:sp>
         <p:nvSpPr>
-          <p:cNvPr id="9" name="TextBox 8"/>
+          <p:cNvPr id="14" name="TextBox 13"/>
           <p:cNvSpPr txBox="1"/>
           <p:nvPr/>
         </p:nvSpPr>
@@ -3479,7 +3677,7 @@
       </p:sp>
       <p:sp>
         <p:nvSpPr>
-          <p:cNvPr id="10" name="TextBox 9"/>
+          <p:cNvPr id="15" name="TextBox 14"/>
           <p:cNvSpPr txBox="1"/>
           <p:nvPr/>
         </p:nvSpPr>
@@ -3596,7 +3794,7 @@
             <a:avLst/>
           </a:prstGeom>
           <a:solidFill>
-            <a:srgbClr val="0E5A54"/>
+            <a:srgbClr val="1466C7"/>
           </a:solidFill>
           <a:ln>
             <a:noFill/>
@@ -3640,7 +3838,7 @@
             <a:avLst/>
           </a:prstGeom>
           <a:solidFill>
-            <a:srgbClr val="DC6B4F"/>
+            <a:srgbClr val="E0930F"/>
           </a:solidFill>
           <a:ln>
             <a:noFill/>
@@ -3702,7 +3900,7 @@
             <a:r>
               <a:rPr sz="1250" b="1">
                 <a:solidFill>
-                  <a:srgbClr val="DC6B4F"/>
+                  <a:srgbClr val="E0930F"/>
                 </a:solidFill>
                 <a:latin typeface="Calibri"/>
               </a:rPr>
@@ -3744,7 +3942,7 @@
             <a:r>
               <a:rPr sz="3200" b="1">
                 <a:solidFill>
-                  <a:srgbClr val="0E5A54"/>
+                  <a:srgbClr val="1466C7"/>
                 </a:solidFill>
                 <a:latin typeface="Georgia"/>
               </a:rPr>
@@ -3854,7 +4052,7 @@
             <a:avLst/>
           </a:prstGeom>
           <a:solidFill>
-            <a:srgbClr val="DC6B4F"/>
+            <a:srgbClr val="E0930F"/>
           </a:solidFill>
           <a:ln>
             <a:noFill/>
@@ -3916,7 +4114,7 @@
             <a:r>
               <a:rPr sz="1800" b="1">
                 <a:solidFill>
-                  <a:srgbClr val="0E5A54"/>
+                  <a:srgbClr val="1466C7"/>
                 </a:solidFill>
                 <a:latin typeface="Calibri"/>
               </a:rPr>
@@ -4026,7 +4224,7 @@
             <a:avLst/>
           </a:prstGeom>
           <a:solidFill>
-            <a:srgbClr val="DC6B4F"/>
+            <a:srgbClr val="E0930F"/>
           </a:solidFill>
           <a:ln>
             <a:noFill/>
@@ -4088,7 +4286,7 @@
             <a:r>
               <a:rPr sz="1800" b="1">
                 <a:solidFill>
-                  <a:srgbClr val="0E5A54"/>
+                  <a:srgbClr val="1466C7"/>
                 </a:solidFill>
                 <a:latin typeface="Calibri"/>
               </a:rPr>
@@ -4300,7 +4498,7 @@
             <a:avLst/>
           </a:prstGeom>
           <a:solidFill>
-            <a:srgbClr val="0E5A54"/>
+            <a:srgbClr val="1466C7"/>
           </a:solidFill>
           <a:ln>
             <a:noFill/>
@@ -4344,7 +4542,7 @@
             <a:avLst/>
           </a:prstGeom>
           <a:solidFill>
-            <a:srgbClr val="DC6B4F"/>
+            <a:srgbClr val="E0930F"/>
           </a:solidFill>
           <a:ln>
             <a:noFill/>
@@ -4406,7 +4604,7 @@
             <a:r>
               <a:rPr sz="1250" b="1">
                 <a:solidFill>
-                  <a:srgbClr val="DC6B4F"/>
+                  <a:srgbClr val="E0930F"/>
                 </a:solidFill>
                 <a:latin typeface="Calibri"/>
               </a:rPr>
@@ -4448,7 +4646,7 @@
             <a:r>
               <a:rPr sz="3200" b="1">
                 <a:solidFill>
-                  <a:srgbClr val="0E5A54"/>
+                  <a:srgbClr val="1466C7"/>
                 </a:solidFill>
                 <a:latin typeface="Georgia"/>
               </a:rPr>
@@ -4558,7 +4756,7 @@
             <a:avLst/>
           </a:prstGeom>
           <a:solidFill>
-            <a:srgbClr val="DC6B4F"/>
+            <a:srgbClr val="E0930F"/>
           </a:solidFill>
           <a:ln>
             <a:noFill/>
@@ -4620,7 +4818,7 @@
             <a:r>
               <a:rPr sz="1800" b="1">
                 <a:solidFill>
-                  <a:srgbClr val="0E5A54"/>
+                  <a:srgbClr val="1466C7"/>
                 </a:solidFill>
                 <a:latin typeface="Calibri"/>
               </a:rPr>
@@ -4730,7 +4928,7 @@
             <a:avLst/>
           </a:prstGeom>
           <a:solidFill>
-            <a:srgbClr val="DC6B4F"/>
+            <a:srgbClr val="E0930F"/>
           </a:solidFill>
           <a:ln>
             <a:noFill/>
@@ -4792,7 +4990,7 @@
             <a:r>
               <a:rPr sz="1800" b="1">
                 <a:solidFill>
-                  <a:srgbClr val="0E5A54"/>
+                  <a:srgbClr val="1466C7"/>
                 </a:solidFill>
                 <a:latin typeface="Calibri"/>
               </a:rPr>
@@ -4858,7 +5056,7 @@
             <a:avLst/>
           </a:prstGeom>
           <a:solidFill>
-            <a:srgbClr val="0E5A54"/>
+            <a:srgbClr val="1466C7"/>
           </a:solidFill>
           <a:ln>
             <a:noFill/>
@@ -5090,7 +5288,7 @@
             <a:avLst/>
           </a:prstGeom>
           <a:solidFill>
-            <a:srgbClr val="0E5A54"/>
+            <a:srgbClr val="1466C7"/>
           </a:solidFill>
           <a:ln>
             <a:noFill/>
@@ -5134,7 +5332,7 @@
             <a:avLst/>
           </a:prstGeom>
           <a:solidFill>
-            <a:srgbClr val="DC6B4F"/>
+            <a:srgbClr val="E0930F"/>
           </a:solidFill>
           <a:ln>
             <a:noFill/>
@@ -5196,7 +5394,7 @@
             <a:r>
               <a:rPr sz="1250" b="1">
                 <a:solidFill>
-                  <a:srgbClr val="DC6B4F"/>
+                  <a:srgbClr val="E0930F"/>
                 </a:solidFill>
                 <a:latin typeface="Calibri"/>
               </a:rPr>
@@ -5238,7 +5436,7 @@
             <a:r>
               <a:rPr sz="3200" b="1">
                 <a:solidFill>
-                  <a:srgbClr val="0E5A54"/>
+                  <a:srgbClr val="1466C7"/>
                 </a:solidFill>
                 <a:latin typeface="Georgia"/>
               </a:rPr>
@@ -5280,7 +5478,7 @@
             <a:r>
               <a:rPr sz="1100" b="1">
                 <a:solidFill>
-                  <a:srgbClr val="DC6B4F"/>
+                  <a:srgbClr val="E0930F"/>
                 </a:solidFill>
                 <a:latin typeface="Calibri"/>
               </a:rPr>
@@ -5317,7 +5515,7 @@
             <a:r>
               <a:rPr sz="1100" b="1">
                 <a:solidFill>
-                  <a:srgbClr val="DC6B4F"/>
+                  <a:srgbClr val="E0930F"/>
                 </a:solidFill>
                 <a:latin typeface="Calibri"/>
               </a:rPr>
@@ -5354,7 +5552,7 @@
             <a:r>
               <a:rPr sz="1100" b="1">
                 <a:solidFill>
-                  <a:srgbClr val="DC6B4F"/>
+                  <a:srgbClr val="E0930F"/>
                 </a:solidFill>
                 <a:latin typeface="Calibri"/>
               </a:rPr>
@@ -5391,7 +5589,7 @@
             <a:r>
               <a:rPr sz="1100" b="1">
                 <a:solidFill>
-                  <a:srgbClr val="DC6B4F"/>
+                  <a:srgbClr val="E0930F"/>
                 </a:solidFill>
                 <a:latin typeface="Calibri"/>
               </a:rPr>
@@ -5428,7 +5626,7 @@
             <a:r>
               <a:rPr sz="1100" b="1">
                 <a:solidFill>
-                  <a:srgbClr val="DC6B4F"/>
+                  <a:srgbClr val="E0930F"/>
                 </a:solidFill>
                 <a:latin typeface="Calibri"/>
               </a:rPr>
@@ -5488,7 +5686,7 @@
             <a:r>
               <a:rPr sz="1100" b="1">
                 <a:solidFill>
-                  <a:srgbClr val="DC6B4F"/>
+                  <a:srgbClr val="E0930F"/>
                 </a:solidFill>
                 <a:latin typeface="Calibri"/>
               </a:rPr>
@@ -5525,7 +5723,7 @@
             <a:r>
               <a:rPr sz="1100" b="1">
                 <a:solidFill>
-                  <a:srgbClr val="DC6B4F"/>
+                  <a:srgbClr val="E0930F"/>
                 </a:solidFill>
                 <a:latin typeface="Calibri"/>
               </a:rPr>
@@ -5562,7 +5760,7 @@
             <a:r>
               <a:rPr sz="1100" b="1">
                 <a:solidFill>
-                  <a:srgbClr val="DC6B4F"/>
+                  <a:srgbClr val="E0930F"/>
                 </a:solidFill>
                 <a:latin typeface="Calibri"/>
               </a:rPr>
@@ -5599,7 +5797,7 @@
             <a:r>
               <a:rPr sz="1100" b="1">
                 <a:solidFill>
-                  <a:srgbClr val="DC6B4F"/>
+                  <a:srgbClr val="E0930F"/>
                 </a:solidFill>
                 <a:latin typeface="Calibri"/>
               </a:rPr>
@@ -5787,7 +5985,7 @@
             <a:avLst/>
           </a:prstGeom>
           <a:solidFill>
-            <a:srgbClr val="0E5A54"/>
+            <a:srgbClr val="1466C7"/>
           </a:solidFill>
           <a:ln>
             <a:noFill/>
@@ -5831,7 +6029,7 @@
             <a:avLst/>
           </a:prstGeom>
           <a:solidFill>
-            <a:srgbClr val="DC6B4F"/>
+            <a:srgbClr val="E0930F"/>
           </a:solidFill>
           <a:ln>
             <a:noFill/>
@@ -5893,7 +6091,7 @@
             <a:r>
               <a:rPr sz="1250" b="1">
                 <a:solidFill>
-                  <a:srgbClr val="DC6B4F"/>
+                  <a:srgbClr val="E0930F"/>
                 </a:solidFill>
                 <a:latin typeface="Calibri"/>
               </a:rPr>
@@ -5935,7 +6133,7 @@
             <a:r>
               <a:rPr sz="3200" b="1">
                 <a:solidFill>
-                  <a:srgbClr val="0E5A54"/>
+                  <a:srgbClr val="1466C7"/>
                 </a:solidFill>
                 <a:latin typeface="Georgia"/>
               </a:rPr>
@@ -6005,7 +6203,7 @@
             <a:avLst/>
           </a:prstGeom>
           <a:solidFill>
-            <a:srgbClr val="DC6B4F"/>
+            <a:srgbClr val="E0930F"/>
           </a:solidFill>
           <a:ln>
             <a:noFill/>
@@ -6067,7 +6265,7 @@
             <a:r>
               <a:rPr sz="1600" b="1">
                 <a:solidFill>
-                  <a:srgbClr val="0E5A54"/>
+                  <a:srgbClr val="1466C7"/>
                 </a:solidFill>
                 <a:latin typeface="Calibri"/>
               </a:rPr>
@@ -6179,7 +6377,7 @@
             <a:avLst/>
           </a:prstGeom>
           <a:solidFill>
-            <a:srgbClr val="DC6B4F"/>
+            <a:srgbClr val="E0930F"/>
           </a:solidFill>
           <a:ln>
             <a:noFill/>
@@ -6241,7 +6439,7 @@
             <a:r>
               <a:rPr sz="1600" b="1">
                 <a:solidFill>
-                  <a:srgbClr val="0E5A54"/>
+                  <a:srgbClr val="1466C7"/>
                 </a:solidFill>
                 <a:latin typeface="Calibri"/>
               </a:rPr>
@@ -6353,7 +6551,7 @@
             <a:avLst/>
           </a:prstGeom>
           <a:solidFill>
-            <a:srgbClr val="DC6B4F"/>
+            <a:srgbClr val="E0930F"/>
           </a:solidFill>
           <a:ln>
             <a:noFill/>
@@ -6415,7 +6613,7 @@
             <a:r>
               <a:rPr sz="1600" b="1">
                 <a:solidFill>
-                  <a:srgbClr val="0E5A54"/>
+                  <a:srgbClr val="1466C7"/>
                 </a:solidFill>
                 <a:latin typeface="Calibri"/>
               </a:rPr>
@@ -6527,7 +6725,7 @@
             <a:avLst/>
           </a:prstGeom>
           <a:solidFill>
-            <a:srgbClr val="DC6B4F"/>
+            <a:srgbClr val="E0930F"/>
           </a:solidFill>
           <a:ln>
             <a:noFill/>
@@ -6589,7 +6787,7 @@
             <a:r>
               <a:rPr sz="1600" b="1">
                 <a:solidFill>
-                  <a:srgbClr val="0E5A54"/>
+                  <a:srgbClr val="1466C7"/>
                 </a:solidFill>
                 <a:latin typeface="Calibri"/>
               </a:rPr>
@@ -6701,7 +6899,7 @@
             <a:avLst/>
           </a:prstGeom>
           <a:solidFill>
-            <a:srgbClr val="DC6B4F"/>
+            <a:srgbClr val="E0930F"/>
           </a:solidFill>
           <a:ln>
             <a:noFill/>
@@ -6763,7 +6961,7 @@
             <a:r>
               <a:rPr sz="1600" b="1">
                 <a:solidFill>
-                  <a:srgbClr val="0E5A54"/>
+                  <a:srgbClr val="1466C7"/>
                 </a:solidFill>
                 <a:latin typeface="Calibri"/>
               </a:rPr>
@@ -6875,7 +7073,7 @@
             <a:avLst/>
           </a:prstGeom>
           <a:solidFill>
-            <a:srgbClr val="DC6B4F"/>
+            <a:srgbClr val="E0930F"/>
           </a:solidFill>
           <a:ln>
             <a:noFill/>
@@ -6937,7 +7135,7 @@
             <a:r>
               <a:rPr sz="1600" b="1">
                 <a:solidFill>
-                  <a:srgbClr val="0E5A54"/>
+                  <a:srgbClr val="1466C7"/>
                 </a:solidFill>
                 <a:latin typeface="Calibri"/>
               </a:rPr>
@@ -7049,7 +7247,7 @@
             <a:avLst/>
           </a:prstGeom>
           <a:solidFill>
-            <a:srgbClr val="DC6B4F"/>
+            <a:srgbClr val="E0930F"/>
           </a:solidFill>
           <a:ln>
             <a:noFill/>
@@ -7111,7 +7309,7 @@
             <a:r>
               <a:rPr sz="1600" b="1">
                 <a:solidFill>
-                  <a:srgbClr val="0E5A54"/>
+                  <a:srgbClr val="1466C7"/>
                 </a:solidFill>
                 <a:latin typeface="Calibri"/>
               </a:rPr>
@@ -7223,7 +7421,7 @@
             <a:avLst/>
           </a:prstGeom>
           <a:solidFill>
-            <a:srgbClr val="DC6B4F"/>
+            <a:srgbClr val="E0930F"/>
           </a:solidFill>
           <a:ln>
             <a:noFill/>
@@ -7285,7 +7483,7 @@
             <a:r>
               <a:rPr sz="1600" b="1">
                 <a:solidFill>
-                  <a:srgbClr val="0E5A54"/>
+                  <a:srgbClr val="1466C7"/>
                 </a:solidFill>
                 <a:latin typeface="Calibri"/>
               </a:rPr>
@@ -7497,7 +7695,7 @@
             <a:avLst/>
           </a:prstGeom>
           <a:solidFill>
-            <a:srgbClr val="0E5A54"/>
+            <a:srgbClr val="1466C7"/>
           </a:solidFill>
           <a:ln>
             <a:noFill/>
@@ -7541,7 +7739,7 @@
             <a:avLst/>
           </a:prstGeom>
           <a:solidFill>
-            <a:srgbClr val="DC6B4F"/>
+            <a:srgbClr val="E0930F"/>
           </a:solidFill>
           <a:ln>
             <a:noFill/>
@@ -7603,7 +7801,7 @@
             <a:r>
               <a:rPr sz="1250" b="1">
                 <a:solidFill>
-                  <a:srgbClr val="DC6B4F"/>
+                  <a:srgbClr val="E0930F"/>
                 </a:solidFill>
                 <a:latin typeface="Calibri"/>
               </a:rPr>
@@ -7645,7 +7843,7 @@
             <a:r>
               <a:rPr sz="3200" b="1">
                 <a:solidFill>
-                  <a:srgbClr val="0E5A54"/>
+                  <a:srgbClr val="1466C7"/>
                 </a:solidFill>
                 <a:latin typeface="Georgia"/>
               </a:rPr>
@@ -7715,7 +7913,7 @@
             <a:avLst/>
           </a:prstGeom>
           <a:solidFill>
-            <a:srgbClr val="0E5A54"/>
+            <a:srgbClr val="1466C7"/>
           </a:solidFill>
           <a:ln>
             <a:noFill/>
@@ -7819,7 +8017,7 @@
             <a:r>
               <a:rPr sz="1450" b="1">
                 <a:solidFill>
-                  <a:srgbClr val="0E5A54"/>
+                  <a:srgbClr val="1466C7"/>
                 </a:solidFill>
                 <a:latin typeface="Calibri"/>
               </a:rPr>
@@ -7903,7 +8101,7 @@
             <a:r>
               <a:rPr sz="2200" b="1">
                 <a:solidFill>
-                  <a:srgbClr val="DC6B4F"/>
+                  <a:srgbClr val="E0930F"/>
                 </a:solidFill>
                 <a:latin typeface="Calibri"/>
               </a:rPr>
@@ -7973,7 +8171,7 @@
             <a:avLst/>
           </a:prstGeom>
           <a:solidFill>
-            <a:srgbClr val="0E5A54"/>
+            <a:srgbClr val="1466C7"/>
           </a:solidFill>
           <a:ln>
             <a:noFill/>
@@ -8077,7 +8275,7 @@
             <a:r>
               <a:rPr sz="1450" b="1">
                 <a:solidFill>
-                  <a:srgbClr val="0E5A54"/>
+                  <a:srgbClr val="1466C7"/>
                 </a:solidFill>
                 <a:latin typeface="Calibri"/>
               </a:rPr>
@@ -8161,7 +8359,7 @@
             <a:r>
               <a:rPr sz="2200" b="1">
                 <a:solidFill>
-                  <a:srgbClr val="DC6B4F"/>
+                  <a:srgbClr val="E0930F"/>
                 </a:solidFill>
                 <a:latin typeface="Calibri"/>
               </a:rPr>
@@ -8231,7 +8429,7 @@
             <a:avLst/>
           </a:prstGeom>
           <a:solidFill>
-            <a:srgbClr val="0E5A54"/>
+            <a:srgbClr val="1466C7"/>
           </a:solidFill>
           <a:ln>
             <a:noFill/>
@@ -8335,7 +8533,7 @@
             <a:r>
               <a:rPr sz="1450" b="1">
                 <a:solidFill>
-                  <a:srgbClr val="0E5A54"/>
+                  <a:srgbClr val="1466C7"/>
                 </a:solidFill>
                 <a:latin typeface="Calibri"/>
               </a:rPr>
@@ -8419,7 +8617,7 @@
             <a:r>
               <a:rPr sz="2200" b="1">
                 <a:solidFill>
-                  <a:srgbClr val="DC6B4F"/>
+                  <a:srgbClr val="E0930F"/>
                 </a:solidFill>
                 <a:latin typeface="Calibri"/>
               </a:rPr>
@@ -8489,7 +8687,7 @@
             <a:avLst/>
           </a:prstGeom>
           <a:solidFill>
-            <a:srgbClr val="DC6B4F"/>
+            <a:srgbClr val="E0930F"/>
           </a:solidFill>
           <a:ln>
             <a:noFill/>
@@ -8593,7 +8791,7 @@
             <a:r>
               <a:rPr sz="1450" b="1">
                 <a:solidFill>
-                  <a:srgbClr val="0E5A54"/>
+                  <a:srgbClr val="1466C7"/>
                 </a:solidFill>
                 <a:latin typeface="Calibri"/>
               </a:rPr>
@@ -8677,7 +8875,7 @@
             <a:r>
               <a:rPr sz="2200" b="1">
                 <a:solidFill>
-                  <a:srgbClr val="DC6B4F"/>
+                  <a:srgbClr val="E0930F"/>
                 </a:solidFill>
                 <a:latin typeface="Calibri"/>
               </a:rPr>
@@ -8851,7 +9049,7 @@
             <a:r>
               <a:rPr sz="1450" b="1">
                 <a:solidFill>
-                  <a:srgbClr val="0E5A54"/>
+                  <a:srgbClr val="1466C7"/>
                 </a:solidFill>
                 <a:latin typeface="Calibri"/>
               </a:rPr>
@@ -9105,7 +9303,7 @@
             <a:avLst/>
           </a:prstGeom>
           <a:solidFill>
-            <a:srgbClr val="0E5A54"/>
+            <a:srgbClr val="1466C7"/>
           </a:solidFill>
           <a:ln>
             <a:noFill/>
@@ -9149,7 +9347,7 @@
             <a:avLst/>
           </a:prstGeom>
           <a:solidFill>
-            <a:srgbClr val="DC6B4F"/>
+            <a:srgbClr val="E0930F"/>
           </a:solidFill>
           <a:ln>
             <a:noFill/>
@@ -9211,7 +9409,7 @@
             <a:r>
               <a:rPr sz="1250" b="1">
                 <a:solidFill>
-                  <a:srgbClr val="DC6B4F"/>
+                  <a:srgbClr val="E0930F"/>
                 </a:solidFill>
                 <a:latin typeface="Calibri"/>
               </a:rPr>
@@ -9253,7 +9451,7 @@
             <a:r>
               <a:rPr sz="3200" b="1">
                 <a:solidFill>
-                  <a:srgbClr val="0E5A54"/>
+                  <a:srgbClr val="1466C7"/>
                 </a:solidFill>
                 <a:latin typeface="Georgia"/>
               </a:rPr>
@@ -9323,7 +9521,7 @@
             <a:avLst/>
           </a:prstGeom>
           <a:solidFill>
-            <a:srgbClr val="DC6B4F"/>
+            <a:srgbClr val="E0930F"/>
           </a:solidFill>
           <a:ln>
             <a:noFill/>
@@ -9367,7 +9565,7 @@
             <a:avLst/>
           </a:prstGeom>
           <a:solidFill>
-            <a:srgbClr val="DC6B4F"/>
+            <a:srgbClr val="E0930F"/>
           </a:solidFill>
           <a:ln>
             <a:noFill/>
@@ -9471,7 +9669,7 @@
             <a:r>
               <a:rPr sz="1300" b="1">
                 <a:solidFill>
-                  <a:srgbClr val="DC6B4F"/>
+                  <a:srgbClr val="E0930F"/>
                 </a:solidFill>
                 <a:latin typeface="Calibri"/>
               </a:rPr>
@@ -9513,7 +9711,7 @@
             <a:r>
               <a:rPr sz="1100" b="1">
                 <a:solidFill>
-                  <a:srgbClr val="DC6B4F"/>
+                  <a:srgbClr val="E0930F"/>
                 </a:solidFill>
                 <a:latin typeface="Calibri"/>
               </a:rPr>
@@ -9541,7 +9739,7 @@
             <a:r>
               <a:rPr sz="1100" b="1">
                 <a:solidFill>
-                  <a:srgbClr val="DC6B4F"/>
+                  <a:srgbClr val="E0930F"/>
                 </a:solidFill>
                 <a:latin typeface="Calibri"/>
               </a:rPr>
@@ -9569,7 +9767,7 @@
             <a:r>
               <a:rPr sz="1100" b="1">
                 <a:solidFill>
-                  <a:srgbClr val="DC6B4F"/>
+                  <a:srgbClr val="E0930F"/>
                 </a:solidFill>
                 <a:latin typeface="Calibri"/>
               </a:rPr>
@@ -9597,7 +9795,7 @@
             <a:r>
               <a:rPr sz="1100" b="1">
                 <a:solidFill>
-                  <a:srgbClr val="DC6B4F"/>
+                  <a:srgbClr val="E0930F"/>
                 </a:solidFill>
                 <a:latin typeface="Calibri"/>
               </a:rPr>
@@ -9866,7 +10064,7 @@
             <a:r>
               <a:rPr sz="1100" b="1">
                 <a:solidFill>
-                  <a:srgbClr val="DC6B4F"/>
+                  <a:srgbClr val="E0930F"/>
                 </a:solidFill>
                 <a:latin typeface="Calibri"/>
               </a:rPr>
@@ -9894,7 +10092,7 @@
             <a:r>
               <a:rPr sz="1100" b="1">
                 <a:solidFill>
-                  <a:srgbClr val="DC6B4F"/>
+                  <a:srgbClr val="E0930F"/>
                 </a:solidFill>
                 <a:latin typeface="Calibri"/>
               </a:rPr>
@@ -9922,7 +10120,7 @@
             <a:r>
               <a:rPr sz="1100" b="1">
                 <a:solidFill>
-                  <a:srgbClr val="DC6B4F"/>
+                  <a:srgbClr val="E0930F"/>
                 </a:solidFill>
                 <a:latin typeface="Calibri"/>
               </a:rPr>
@@ -10191,7 +10389,7 @@
             <a:r>
               <a:rPr sz="1100" b="1">
                 <a:solidFill>
-                  <a:srgbClr val="DC6B4F"/>
+                  <a:srgbClr val="E0930F"/>
                 </a:solidFill>
                 <a:latin typeface="Calibri"/>
               </a:rPr>
@@ -10219,7 +10417,7 @@
             <a:r>
               <a:rPr sz="1100" b="1">
                 <a:solidFill>
-                  <a:srgbClr val="DC6B4F"/>
+                  <a:srgbClr val="E0930F"/>
                 </a:solidFill>
                 <a:latin typeface="Calibri"/>
               </a:rPr>
@@ -10247,7 +10445,7 @@
             <a:r>
               <a:rPr sz="1100" b="1">
                 <a:solidFill>
-                  <a:srgbClr val="DC6B4F"/>
+                  <a:srgbClr val="E0930F"/>
                 </a:solidFill>
                 <a:latin typeface="Calibri"/>
               </a:rPr>
@@ -10426,7 +10624,7 @@
             <a:avLst/>
           </a:prstGeom>
           <a:solidFill>
-            <a:srgbClr val="0E5A54"/>
+            <a:srgbClr val="1466C7"/>
           </a:solidFill>
           <a:ln>
             <a:noFill/>
@@ -10470,7 +10668,7 @@
             <a:avLst/>
           </a:prstGeom>
           <a:solidFill>
-            <a:srgbClr val="DC6B4F"/>
+            <a:srgbClr val="E0930F"/>
           </a:solidFill>
           <a:ln>
             <a:noFill/>
@@ -10532,7 +10730,7 @@
             <a:r>
               <a:rPr sz="1250" b="1">
                 <a:solidFill>
-                  <a:srgbClr val="DC6B4F"/>
+                  <a:srgbClr val="E0930F"/>
                 </a:solidFill>
                 <a:latin typeface="Calibri"/>
               </a:rPr>
@@ -10574,7 +10772,7 @@
             <a:r>
               <a:rPr sz="3200" b="1">
                 <a:solidFill>
-                  <a:srgbClr val="0E5A54"/>
+                  <a:srgbClr val="1466C7"/>
                 </a:solidFill>
                 <a:latin typeface="Georgia"/>
               </a:rPr>
@@ -10616,7 +10814,7 @@
             <a:r>
               <a:rPr sz="1100" b="1">
                 <a:solidFill>
-                  <a:srgbClr val="DC6B4F"/>
+                  <a:srgbClr val="E0930F"/>
                 </a:solidFill>
                 <a:latin typeface="Calibri"/>
               </a:rPr>
@@ -10653,7 +10851,7 @@
             <a:r>
               <a:rPr sz="1100" b="1">
                 <a:solidFill>
-                  <a:srgbClr val="DC6B4F"/>
+                  <a:srgbClr val="E0930F"/>
                 </a:solidFill>
                 <a:latin typeface="Calibri"/>
               </a:rPr>
@@ -10690,7 +10888,7 @@
             <a:r>
               <a:rPr sz="1100" b="1">
                 <a:solidFill>
-                  <a:srgbClr val="DC6B4F"/>
+                  <a:srgbClr val="E0930F"/>
                 </a:solidFill>
                 <a:latin typeface="Calibri"/>
               </a:rPr>
@@ -10727,7 +10925,7 @@
             <a:r>
               <a:rPr sz="1100" b="1">
                 <a:solidFill>
-                  <a:srgbClr val="DC6B4F"/>
+                  <a:srgbClr val="E0930F"/>
                 </a:solidFill>
                 <a:latin typeface="Calibri"/>
               </a:rPr>
@@ -10787,7 +10985,7 @@
             <a:r>
               <a:rPr sz="1100" b="1">
                 <a:solidFill>
-                  <a:srgbClr val="DC6B4F"/>
+                  <a:srgbClr val="E0930F"/>
                 </a:solidFill>
                 <a:latin typeface="Calibri"/>
               </a:rPr>
@@ -10824,7 +11022,7 @@
             <a:r>
               <a:rPr sz="1100" b="1">
                 <a:solidFill>
-                  <a:srgbClr val="DC6B4F"/>
+                  <a:srgbClr val="E0930F"/>
                 </a:solidFill>
                 <a:latin typeface="Calibri"/>
               </a:rPr>
@@ -10861,7 +11059,7 @@
             <a:r>
               <a:rPr sz="1100" b="1">
                 <a:solidFill>
-                  <a:srgbClr val="DC6B4F"/>
+                  <a:srgbClr val="E0930F"/>
                 </a:solidFill>
                 <a:latin typeface="Calibri"/>
               </a:rPr>
@@ -10898,7 +11096,7 @@
             <a:r>
               <a:rPr sz="1100" b="1">
                 <a:solidFill>
-                  <a:srgbClr val="DC6B4F"/>
+                  <a:srgbClr val="E0930F"/>
                 </a:solidFill>
                 <a:latin typeface="Calibri"/>
               </a:rPr>
@@ -11002,7 +11200,7 @@
             <a:r>
               <a:rPr sz="1350" b="1">
                 <a:solidFill>
-                  <a:srgbClr val="0E5A54"/>
+                  <a:srgbClr val="1466C7"/>
                 </a:solidFill>
                 <a:latin typeface="Calibri"/>
               </a:rPr>

</xml_diff>